<commit_message>
Fix merged bullet points on leerdoelen and samenvatting slides
Split single-paragraph merged text into proper separate bullet points
on 25 slides across 14 presentations. Root cause: PptxGenJS breakLine
creates <a:br/> soft breaks (one paragraph), not <a:p> hard breaks.

Updated econ-pptx-templates to use items.join("\n") with bullet: true,
which creates proper separate paragraphs. Added warning to NEVER DO list.

Also adds .claude/commands/ with project skill files.

Co-Authored-By: Claude Opus 4.6 (1M context) <noreply@anthropic.com>
</commit_message>
<xml_diff>
--- a/3.1 Hoofdstuk 1 - Markten/3.1.1 Paragraaf 1 - Markt en marktstructuur/2. Leren/3.1.1 Markt en marktstructuur – presentatie.pptx
+++ b/3.1 Hoofdstuk 1 - Markten/3.1.1 Paragraaf 1 - Markt en marktstructuur/2. Leren/3.1.1 Markt en marktstructuur – presentatie.pptx
@@ -1879,6 +1879,8 @@
               </a:rPr>
               <a:t>Concrete en abstracte markten onderscheiden</a:t>
             </a:r>
+          </a:p>
+          <a:p>
             <a:pPr algn="l" marL="342900" indent="-342900">
               <a:lnSpc>
                 <a:spcPct val="150000"/>
@@ -1900,6 +1902,8 @@
               </a:rPr>
               <a:t>Homogene en heterogene producten herkennen</a:t>
             </a:r>
+          </a:p>
+          <a:p>
             <a:pPr algn="l" marL="342900" indent="-342900">
               <a:lnSpc>
                 <a:spcPct val="150000"/>
@@ -1921,6 +1925,8 @@
               </a:rPr>
               <a:t>Toetredingsdrempels analyseren en voorbeelden noemen</a:t>
             </a:r>
+          </a:p>
+          <a:p>
             <a:pPr algn="l" marL="342900" indent="-342900">
               <a:lnSpc>
                 <a:spcPct val="150000"/>
@@ -1942,7 +1948,6 @@
               </a:rPr>
               <a:t>De redeneerketen van drempels naar prijs toepassen</a:t>
             </a:r>
-            <a:endParaRPr lang="en-US" sz="1500" dirty="0"/>
           </a:p>
         </p:txBody>
       </p:sp>
@@ -2038,6 +2043,10 @@
             </a:outerShdw>
           </a:effectLst>
         </p:spPr>
+        <p:txBody>
+          <a:bodyPr/>
+          <a:p/>
+        </p:txBody>
       </p:sp>
       <p:sp>
         <p:nvSpPr>
@@ -2058,6 +2067,10 @@
           </a:solidFill>
           <a:ln/>
         </p:spPr>
+        <p:txBody>
+          <a:bodyPr/>
+          <a:p/>
+        </p:txBody>
       </p:sp>
       <p:sp>
         <p:nvSpPr>
@@ -2203,6 +2216,10 @@
             </a:outerShdw>
           </a:effectLst>
         </p:spPr>
+        <p:txBody>
+          <a:bodyPr/>
+          <a:p/>
+        </p:txBody>
       </p:sp>
       <p:sp>
         <p:nvSpPr>
@@ -2223,6 +2240,10 @@
           </a:solidFill>
           <a:ln/>
         </p:spPr>
+        <p:txBody>
+          <a:bodyPr/>
+          <a:p/>
+        </p:txBody>
       </p:sp>
       <p:sp>
         <p:nvSpPr>
@@ -2432,6 +2453,10 @@
             </a:outerShdw>
           </a:effectLst>
         </p:spPr>
+        <p:txBody>
+          <a:bodyPr/>
+          <a:p/>
+        </p:txBody>
       </p:sp>
       <p:sp>
         <p:nvSpPr>
@@ -2452,6 +2477,10 @@
           </a:solidFill>
           <a:ln/>
         </p:spPr>
+        <p:txBody>
+          <a:bodyPr/>
+          <a:p/>
+        </p:txBody>
       </p:sp>
       <p:sp>
         <p:nvSpPr>
@@ -2597,6 +2626,10 @@
             </a:outerShdw>
           </a:effectLst>
         </p:spPr>
+        <p:txBody>
+          <a:bodyPr/>
+          <a:p/>
+        </p:txBody>
       </p:sp>
       <p:sp>
         <p:nvSpPr>
@@ -2617,6 +2650,10 @@
           </a:solidFill>
           <a:ln/>
         </p:spPr>
+        <p:txBody>
+          <a:bodyPr/>
+          <a:p/>
+        </p:txBody>
       </p:sp>
       <p:sp>
         <p:nvSpPr>
@@ -2865,6 +2902,10 @@
             </a:outerShdw>
           </a:effectLst>
         </p:spPr>
+        <p:txBody>
+          <a:bodyPr/>
+          <a:p/>
+        </p:txBody>
       </p:sp>
       <p:sp>
         <p:nvSpPr>
@@ -2885,6 +2926,10 @@
           </a:solidFill>
           <a:ln/>
         </p:spPr>
+        <p:txBody>
+          <a:bodyPr/>
+          <a:p/>
+        </p:txBody>
       </p:sp>
       <p:sp>
         <p:nvSpPr>
@@ -3177,6 +3222,10 @@
             </a:outerShdw>
           </a:effectLst>
         </p:spPr>
+        <p:txBody>
+          <a:bodyPr/>
+          <a:p/>
+        </p:txBody>
       </p:sp>
       <p:sp>
         <p:nvSpPr>
@@ -3289,6 +3338,10 @@
             </a:outerShdw>
           </a:effectLst>
         </p:spPr>
+        <p:txBody>
+          <a:bodyPr/>
+          <a:p/>
+        </p:txBody>
       </p:sp>
       <p:sp>
         <p:nvSpPr>
@@ -3401,6 +3454,10 @@
             </a:outerShdw>
           </a:effectLst>
         </p:spPr>
+        <p:txBody>
+          <a:bodyPr/>
+          <a:p/>
+        </p:txBody>
       </p:sp>
       <p:sp>
         <p:nvSpPr>
@@ -3513,6 +3570,10 @@
             </a:outerShdw>
           </a:effectLst>
         </p:spPr>
+        <p:txBody>
+          <a:bodyPr/>
+          <a:p/>
+        </p:txBody>
       </p:sp>
       <p:sp>
         <p:nvSpPr>
@@ -3645,6 +3706,10 @@
             </a:outerShdw>
           </a:effectLst>
         </p:spPr>
+        <p:txBody>
+          <a:bodyPr/>
+          <a:p/>
+        </p:txBody>
       </p:sp>
       <p:sp>
         <p:nvSpPr>
@@ -3665,6 +3730,10 @@
           </a:solidFill>
           <a:ln/>
         </p:spPr>
+        <p:txBody>
+          <a:bodyPr/>
+          <a:p/>
+        </p:txBody>
       </p:sp>
       <p:sp>
         <p:nvSpPr>
@@ -3810,6 +3879,10 @@
             </a:outerShdw>
           </a:effectLst>
         </p:spPr>
+        <p:txBody>
+          <a:bodyPr/>
+          <a:p/>
+        </p:txBody>
       </p:sp>
       <p:sp>
         <p:nvSpPr>
@@ -3830,6 +3903,10 @@
           </a:solidFill>
           <a:ln/>
         </p:spPr>
+        <p:txBody>
+          <a:bodyPr/>
+          <a:p/>
+        </p:txBody>
       </p:sp>
       <p:sp>
         <p:nvSpPr>
@@ -4092,6 +4169,10 @@
             </a:outerShdw>
           </a:effectLst>
         </p:spPr>
+        <p:txBody>
+          <a:bodyPr/>
+          <a:p/>
+        </p:txBody>
       </p:sp>
       <p:sp>
         <p:nvSpPr>
@@ -4112,6 +4193,10 @@
           </a:solidFill>
           <a:ln/>
         </p:spPr>
+        <p:txBody>
+          <a:bodyPr/>
+          <a:p/>
+        </p:txBody>
       </p:sp>
       <p:sp>
         <p:nvSpPr>
@@ -4219,6 +4304,10 @@
             </a:outerShdw>
           </a:effectLst>
         </p:spPr>
+        <p:txBody>
+          <a:bodyPr/>
+          <a:p/>
+        </p:txBody>
       </p:sp>
       <p:sp>
         <p:nvSpPr>
@@ -4239,6 +4328,10 @@
           </a:solidFill>
           <a:ln/>
         </p:spPr>
+        <p:txBody>
+          <a:bodyPr/>
+          <a:p/>
+        </p:txBody>
       </p:sp>
       <p:sp>
         <p:nvSpPr>
@@ -4346,6 +4439,10 @@
             </a:outerShdw>
           </a:effectLst>
         </p:spPr>
+        <p:txBody>
+          <a:bodyPr/>
+          <a:p/>
+        </p:txBody>
       </p:sp>
       <p:sp>
         <p:nvSpPr>
@@ -4366,6 +4463,10 @@
           </a:solidFill>
           <a:ln/>
         </p:spPr>
+        <p:txBody>
+          <a:bodyPr/>
+          <a:p/>
+        </p:txBody>
       </p:sp>
       <p:sp>
         <p:nvSpPr>
@@ -4590,6 +4691,8 @@
               </a:rPr>
               <a:t>Concrete vs abstracte markten onderscheiden</a:t>
             </a:r>
+          </a:p>
+          <a:p>
             <a:pPr algn="l" marL="342900" indent="-342900">
               <a:lnSpc>
                 <a:spcPct val="160000"/>
@@ -4611,6 +4714,8 @@
               </a:rPr>
               <a:t>Homogeen vs heterogeen: consumentenperceptie telt</a:t>
             </a:r>
+          </a:p>
+          <a:p>
             <a:pPr algn="l" marL="342900" indent="-342900">
               <a:lnSpc>
                 <a:spcPct val="160000"/>
@@ -4632,6 +4737,8 @@
               </a:rPr>
               <a:t>Toetredingsdrempels herkennen</a:t>
             </a:r>
+          </a:p>
+          <a:p>
             <a:pPr algn="l" marL="342900" indent="-342900">
               <a:lnSpc>
                 <a:spcPct val="160000"/>
@@ -4653,6 +4760,8 @@
               </a:rPr>
               <a:t>Redeneerketen: drempels → aanbieders → concurrentie → prijs</a:t>
             </a:r>
+          </a:p>
+          <a:p>
             <a:pPr algn="l" marL="342900" indent="-342900">
               <a:lnSpc>
                 <a:spcPct val="160000"/>
@@ -4674,7 +4783,6 @@
               </a:rPr>
               <a:t>Rol overheid bij netwerksectoren</a:t>
             </a:r>
-            <a:endParaRPr lang="en-US" sz="1500" dirty="0"/>
           </a:p>
         </p:txBody>
       </p:sp>

</xml_diff>